<commit_message>
chore: update weekly digest 2026-09-07
</commit_message>
<xml_diff>
--- a/docs/digest-en.pptx
+++ b/docs/digest-en.pptx
@@ -2249,7 +2249,7 @@
                   <a:srgbClr val="888888"/>
                 </a:solidFill>
               </a:rPr>
-              <a:t>2026-08-24 — 2026-08-31</a:t>
+              <a:t>2026-08-31 — 2026-09-07</a:t>
             </a:r>
             <a:endParaRPr lang="en-US" sz="1400" dirty="0"/>
           </a:p>
@@ -2440,7 +2440,7 @@
                   </a:extLst>
                 </a:hlinkClick>
               </a:rPr>
-              <a:t>Methylparaben promotes colorectal tumor growth through nuclear receptor-mediated transcriptional reprogramming and inflammatory signaling: Evidence from integrated transcriptomics and network toxicology.</a:t>
+              <a:t>Prognostic value of systemic immune-inflammation index for colorectal cancer: a systematic review and meta-analysis</a:t>
             </a:r>
             <a:endParaRPr lang="en-US" sz="2400" dirty="0"/>
           </a:p>
@@ -2476,7 +2476,7 @@
                   <a:srgbClr val="888888"/>
                 </a:solidFill>
               </a:rPr>
-              <a:t>Food and chemical toxicology : an international journal published for the British Industrial Biological Research Association  ·  Basic Research</a:t>
+              <a:t>Frontiers in Oncology  ·  Meta-Analysis</a:t>
             </a:r>
             <a:endParaRPr lang="en-US" sz="1000" dirty="0"/>
           </a:p>
@@ -2555,7 +2555,7 @@
                   <a:srgbClr val="888888"/>
                 </a:solidFill>
               </a:rPr>
-              <a:t>Ma Zhisheng, Zhang Zheng, Zhou Yao et al.. Food and chemical toxicology : an international journal published for the British Industrial Biological Research Association. 2026-08-28 DOI: 10.1016/j.fct.2026.116349</a:t>
+              <a:t>P Wang, H Jiang. Frontiers in Oncology. 2026</a:t>
             </a:r>
             <a:endParaRPr lang="en-US" sz="800" dirty="0"/>
           </a:p>
@@ -2755,7 +2755,7 @@
                   </a:extLst>
                 </a:hlinkClick>
               </a:rPr>
-              <a:t>A conserved Notch-Meis1-Pbx cascade specifies secretory progenitors into spatially diverse intestinal best4 + cells.</a:t>
+              <a:t>Peritoneal Metastases in Stage II-III Colon Cancer Represent a Blind Spot for Circulating Tumor DNA Surveillance.</a:t>
             </a:r>
             <a:endParaRPr lang="en-US" sz="2400" dirty="0"/>
           </a:p>
@@ -2791,7 +2791,7 @@
                   <a:srgbClr val="888888"/>
                 </a:solidFill>
               </a:rPr>
-              <a:t>Genes &amp; development  ·  Basic Research</a:t>
+              <a:t>Annals of surgical oncology  ·  IF 3.8  ·  Prospective Study</a:t>
             </a:r>
             <a:endParaRPr lang="en-US" sz="1000" dirty="0"/>
           </a:p>
@@ -2870,7 +2870,7 @@
                   <a:srgbClr val="888888"/>
                 </a:solidFill>
               </a:rPr>
-              <a:t>Sur Abhinav, Segal Ella X, Nunneley Michael P et al.. Genes &amp; development. 2026-08-26 DOI: 10.1101/gad.353662.126</a:t>
+              <a:t>Ofori Kwasi Ansere, Smart Huxley, Liu Sean et al.. Annals of surgical oncology. 2026-08-11 DOI: 10.1245/s10434-026-19903-8</a:t>
             </a:r>
             <a:endParaRPr lang="en-US" sz="800" dirty="0"/>
           </a:p>
@@ -3070,7 +3070,7 @@
                   </a:extLst>
                 </a:hlinkClick>
               </a:rPr>
-              <a:t>cGAS-STING Modulates the NF-&amp;#x3ba;B Pathway to Influence the Occurrence of Ulcerative Colitis-Associated Colorectal Cancer.</a:t>
+              <a:t>Modulatory role of Blastocystis-derived solubilized antigens in colorectal carcinogenesis: A systematic review.</a:t>
             </a:r>
             <a:endParaRPr lang="en-US" sz="2400" dirty="0"/>
           </a:p>
@@ -3106,7 +3106,7 @@
                   <a:srgbClr val="888888"/>
                 </a:solidFill>
               </a:rPr>
-              <a:t>Digestive diseases and sciences  ·  Basic Research</a:t>
+              <a:t>Molecular and biochemical parasitology  ·  Systematic Review</a:t>
             </a:r>
             <a:endParaRPr lang="en-US" sz="1000" dirty="0"/>
           </a:p>
@@ -3185,7 +3185,7 @@
                   <a:srgbClr val="888888"/>
                 </a:solidFill>
               </a:rPr>
-              <a:t>Wang Jian, Luo Anqing, Yao Yizhou et al.. Digestive diseases and sciences. 2026-08-24 DOI: 10.1007/s10620-026-10183-6</a:t>
+              <a:t>Noor Razali Nur Amani Syakirin, Mohd Akmal Nur Anurah Hani, Wardina Mohd Khir Nur Eisya et al.. Molecular and biochemical parasitology. 2026-08-22 DOI: 10.1016/j.molbiopara.2026.111765</a:t>
             </a:r>
             <a:endParaRPr lang="en-US" sz="800" dirty="0"/>
           </a:p>
@@ -3756,7 +3756,7 @@
                 <a:ea typeface="Arial" pitchFamily="34" charset="-122"/>
                 <a:cs typeface="Arial" pitchFamily="34" charset="-120"/>
               </a:rPr>
-              <a:t>Emerging exposure-driven accelerated colorectal carcinogenesis: a model with imp…</a:t>
+              <a:t>Impact of the number of colorectal cancer lymph node metastases on intraperitone…</a:t>
             </a:r>
             <a:endParaRPr lang="en-US" sz="1400" dirty="0"/>
           </a:p>
@@ -3793,7 +3793,7 @@
                 <a:ea typeface="Arial" pitchFamily="34" charset="-122"/>
                 <a:cs typeface="Arial" pitchFamily="34" charset="-120"/>
               </a:rPr>
-              <a:t>Neoadjuvant chemotherapy and bevacizumab for colorectal peritoneal metastases: c…</a:t>
+              <a:t>Troxerutin as a bioactive flavonoid: Insights into its anticancer mechanisms and…</a:t>
             </a:r>
             <a:endParaRPr lang="en-US" sz="1400" dirty="0"/>
           </a:p>
@@ -3830,7 +3830,7 @@
                 <a:ea typeface="Arial" pitchFamily="34" charset="-122"/>
                 <a:cs typeface="Arial" pitchFamily="34" charset="-120"/>
               </a:rPr>
-              <a:t>Prophylactic Hyperthermic Intraperitoneal Chemotherapy in Locally Advanced Color…</a:t>
+              <a:t>Microbiome-Driven Carcinogenesis and Circulating Microbial Signals in Genitourin…</a:t>
             </a:r>
             <a:endParaRPr lang="en-US" sz="1400" dirty="0"/>
           </a:p>
@@ -3867,7 +3867,7 @@
                 <a:ea typeface="Arial" pitchFamily="34" charset="-122"/>
                 <a:cs typeface="Arial" pitchFamily="34" charset="-120"/>
               </a:rPr>
-              <a:t>Glucosamine Use and Its Association with Colorectal Cancer and Mortality: A Syst…</a:t>
+              <a:t>Single-Port Robotic Cytoreductive Surgery for Colon Cancer Peritoneal Recurrence…</a:t>
             </a:r>
             <a:endParaRPr lang="en-US" sz="1400" dirty="0"/>
           </a:p>
@@ -3904,7 +3904,7 @@
                 <a:ea typeface="Arial" pitchFamily="34" charset="-122"/>
                 <a:cs typeface="Arial" pitchFamily="34" charset="-120"/>
               </a:rPr>
-              <a:t>Prognostic value of pretreatment C-reactive–protein–albumin–lymphocyte index in …</a:t>
+              <a:t>Body mass index, adjuvant chemotherapy, toxicity, and survival in non-metastatic…</a:t>
             </a:r>
             <a:endParaRPr lang="en-US" sz="1400" dirty="0"/>
           </a:p>
@@ -3941,7 +3941,7 @@
                 <a:ea typeface="Arial" pitchFamily="34" charset="-122"/>
                 <a:cs typeface="Arial" pitchFamily="34" charset="-120"/>
               </a:rPr>
-              <a:t>Risk Factors in Sporadic Early-Onset Colorectal Cancer, Current Evidence and Eme…</a:t>
+              <a:t>Anterior Cutaneous Nerve Entrapment Syndrome in a 51-Year-Old Woman With Advance…</a:t>
             </a:r>
             <a:endParaRPr lang="en-US" sz="1400" dirty="0"/>
           </a:p>
@@ -3978,7 +3978,7 @@
                 <a:ea typeface="Arial" pitchFamily="34" charset="-122"/>
                 <a:cs typeface="Arial" pitchFamily="34" charset="-120"/>
               </a:rPr>
-              <a:t>Neutrophil extracellular traps in colorectal cancer: context-dependent roles fro…</a:t>
+              <a:t>Glucosamine Use and Its Association with Colorectal Cancer and Mortality: A Syst…</a:t>
             </a:r>
             <a:endParaRPr lang="en-US" sz="1400" dirty="0"/>
           </a:p>
@@ -4015,7 +4015,7 @@
                 <a:ea typeface="Arial" pitchFamily="34" charset="-122"/>
                 <a:cs typeface="Arial" pitchFamily="34" charset="-120"/>
               </a:rPr>
-              <a:t>Methylparaben promotes colorectal tumor growth through nuclear receptor-mediated…</a:t>
+              <a:t>Prognostic value of systemic immune-inflammation index for colorectal cancer: a …</a:t>
             </a:r>
             <a:endParaRPr lang="en-US" sz="1400" dirty="0"/>
           </a:p>
@@ -4052,7 +4052,7 @@
                 <a:ea typeface="Arial" pitchFamily="34" charset="-122"/>
                 <a:cs typeface="Arial" pitchFamily="34" charset="-120"/>
               </a:rPr>
-              <a:t>A conserved Notch-Meis1-Pbx cascade specifies secretory progenitors into spatial…</a:t>
+              <a:t>Peritoneal Metastases in Stage II-III Colon Cancer Represent a Blind Spot for Ci…</a:t>
             </a:r>
             <a:endParaRPr lang="en-US" sz="1400" dirty="0"/>
           </a:p>
@@ -4089,7 +4089,7 @@
                 <a:ea typeface="Arial" pitchFamily="34" charset="-122"/>
                 <a:cs typeface="Arial" pitchFamily="34" charset="-120"/>
               </a:rPr>
-              <a:t>cGAS-STING Modulates the NF-&amp;#x3ba;B Pathway to Influence the Occurrence of Ulce…</a:t>
+              <a:t>Modulatory role of Blastocystis-derived solubilized antigens in colorectal carci…</a:t>
             </a:r>
             <a:endParaRPr lang="en-US" sz="1400" dirty="0"/>
           </a:p>
@@ -4244,7 +4244,7 @@
                   </a:extLst>
                 </a:hlinkClick>
               </a:rPr>
-              <a:t>Emerging exposure-driven accelerated colorectal carcinogenesis: a model with implications for screening colonoscopy effectiveness</a:t>
+              <a:t>Impact of the number of colorectal cancer lymph node metastases on intraperitoneal lavage cytology: a multi-institutional, prospective, observational study.</a:t>
             </a:r>
             <a:endParaRPr lang="en-US" sz="2400" dirty="0"/>
           </a:p>
@@ -4280,7 +4280,7 @@
                   <a:srgbClr val="888888"/>
                 </a:solidFill>
               </a:rPr>
-              <a:t>Gut  ·  IF 24.5  ·  Prospective Study</a:t>
+              <a:t>Surgery today  ·  Prospective Study  ·  🌏 Asia</a:t>
             </a:r>
             <a:endParaRPr lang="en-US" sz="1000" dirty="0"/>
           </a:p>
@@ -4359,7 +4359,7 @@
                   <a:srgbClr val="888888"/>
                 </a:solidFill>
               </a:rPr>
-              <a:t>K Truninger, H Easwaran, F Macrae. Gut. 2026</a:t>
+              <a:t>Mise Minori, Ozawa Heita, Kobayashi Hirotoshi et al.. Surgery today. 2026-08-13 DOI: 10.1007/s00595-026-03313-0</a:t>
             </a:r>
             <a:endParaRPr lang="en-US" sz="800" dirty="0"/>
           </a:p>
@@ -4559,7 +4559,7 @@
                   </a:extLst>
                 </a:hlinkClick>
               </a:rPr>
-              <a:t>Neoadjuvant chemotherapy and bevacizumab for colorectal peritoneal metastases: clinical and translational outcomes of the phase II BEV-IP trial</a:t>
+              <a:t>Troxerutin as a bioactive flavonoid: Insights into its anticancer mechanisms and therapeutic applications.</a:t>
             </a:r>
             <a:endParaRPr lang="en-US" sz="2400" dirty="0"/>
           </a:p>
@@ -4595,7 +4595,7 @@
                   <a:srgbClr val="888888"/>
                 </a:solidFill>
               </a:rPr>
-              <a:t>Translational …  ·  RCT Phase 2</a:t>
+              <a:t>European journal of medicinal chemistry  ·  Basic Research  ·  🌏 Asia</a:t>
             </a:r>
             <a:endParaRPr lang="en-US" sz="1000" dirty="0"/>
           </a:p>
@@ -4674,7 +4674,7 @@
                   <a:srgbClr val="888888"/>
                 </a:solidFill>
               </a:rPr>
-              <a:t>DKA Chia, J Demuytere, A Hoorens…. Translational …. 2026</a:t>
+              <a:t>Manna Priya, Chatterjee Srijita, Chatterjee Ganguly Shayeri et al.. European journal of medicinal chemistry. 2026-07-15 DOI: 10.1016/j.ejmech.2026.118885</a:t>
             </a:r>
             <a:endParaRPr lang="en-US" sz="800" dirty="0"/>
           </a:p>
@@ -4874,7 +4874,7 @@
                   </a:extLst>
                 </a:hlinkClick>
               </a:rPr>
-              <a:t>Prophylactic Hyperthermic Intraperitoneal Chemotherapy in Locally Advanced Colorectal Cancer: Systematic Review and Meta-Analysis</a:t>
+              <a:t>Microbiome-Driven Carcinogenesis and Circulating Microbial Signals in Genitourinary Cancers.</a:t>
             </a:r>
             <a:endParaRPr lang="en-US" sz="2400" dirty="0"/>
           </a:p>
@@ -4910,7 +4910,7 @@
                   <a:srgbClr val="888888"/>
                 </a:solidFill>
               </a:rPr>
-              <a:t>Annals of Surgical …  ·  Meta-Analysis</a:t>
+              <a:t>Cancer science  ·  Basic Research  ·  🌏 Asia</a:t>
             </a:r>
             <a:endParaRPr lang="en-US" sz="1000" dirty="0"/>
           </a:p>
@@ -4989,7 +4989,7 @@
                   <a:srgbClr val="888888"/>
                 </a:solidFill>
               </a:rPr>
-              <a:t>YC Chen, SC Chang, YY Tsai. Annals of Surgical …. 2026</a:t>
+              <a:t>Kawashima Atsunari, Jingushi Kentaro, Saito Takuro et al.. Cancer science. 2026-09-01 DOI: 10.1111/cas.70448</a:t>
             </a:r>
             <a:endParaRPr lang="en-US" sz="800" dirty="0"/>
           </a:p>
@@ -5189,7 +5189,7 @@
                   </a:extLst>
                 </a:hlinkClick>
               </a:rPr>
-              <a:t>Glucosamine Use and Its Association with Colorectal Cancer and Mortality: A Systematic Review and Meta-Analysis</a:t>
+              <a:t>Single-Port Robotic Cytoreductive Surgery for Colon Cancer Peritoneal Recurrence with the da Vinci SP.</a:t>
             </a:r>
             <a:endParaRPr lang="en-US" sz="2400" dirty="0"/>
           </a:p>
@@ -5225,7 +5225,7 @@
                   <a:srgbClr val="888888"/>
                 </a:solidFill>
               </a:rPr>
-              <a:t>Journal of Cancer  ·  Meta-Analysis</a:t>
+              <a:t>Annals of surgical oncology  ·  IF 3.8  ·  Case Report  ·  🌏 Asia</a:t>
             </a:r>
             <a:endParaRPr lang="en-US" sz="1000" dirty="0"/>
           </a:p>
@@ -5304,7 +5304,7 @@
                   <a:srgbClr val="888888"/>
                 </a:solidFill>
               </a:rPr>
-              <a:t>Y Yan, M Xu, R Wang. Journal of Cancer. 2026</a:t>
+              <a:t>Kwon Hoyeon, Park Soo Yeun. Annals of surgical oncology. 2026-08-11 DOI: 10.1245/s10434-026-19743-6</a:t>
             </a:r>
             <a:endParaRPr lang="en-US" sz="800" dirty="0"/>
           </a:p>
@@ -5504,7 +5504,7 @@
                   </a:extLst>
                 </a:hlinkClick>
               </a:rPr>
-              <a:t>Prognostic value of pretreatment C-reactive–protein–albumin–lymphocyte index in colorectal cancer: systematic review and meta-analysis</a:t>
+              <a:t>Body mass index, adjuvant chemotherapy, toxicity, and survival in non-metastatic colorectal cancer: an individual participant data meta-analysis (OCTOPUS).</a:t>
             </a:r>
             <a:endParaRPr lang="en-US" sz="2400" dirty="0"/>
           </a:p>
@@ -5540,7 +5540,7 @@
                   <a:srgbClr val="888888"/>
                 </a:solidFill>
               </a:rPr>
-              <a:t>Journal of …  ·  Meta-Analysis</a:t>
+              <a:t>British journal of cancer  ·  IF 6.4  ·  Meta-Analysis</a:t>
             </a:r>
             <a:endParaRPr lang="en-US" sz="1000" dirty="0"/>
           </a:p>
@@ -5619,7 +5619,7 @@
                   <a:srgbClr val="888888"/>
                 </a:solidFill>
               </a:rPr>
-              <a:t>M Shamohammadi, D Yarahmadi…. Journal of …. 2026</a:t>
+              <a:t>Slawinski Corinna G V, Malcomson Lee, Barriuso Jorge et al.. British journal of cancer. 2026-08-16 DOI: 10.1038/s41416-026-03472-4</a:t>
             </a:r>
             <a:endParaRPr lang="en-US" sz="800" dirty="0"/>
           </a:p>
@@ -5819,7 +5819,7 @@
                   </a:extLst>
                 </a:hlinkClick>
               </a:rPr>
-              <a:t>Risk Factors in Sporadic Early-Onset Colorectal Cancer, Current Evidence and Emerging Insights: A Systematic Review</a:t>
+              <a:t>Anterior Cutaneous Nerve Entrapment Syndrome in a 51-Year-Old Woman With Advanced Colon Cancer, Successfully Treated With Repeated Ultrasound-Guided Rectus Sheath Blocks: A Case Report.</a:t>
             </a:r>
             <a:endParaRPr lang="en-US" sz="2400" dirty="0"/>
           </a:p>
@@ -5855,7 +5855,7 @@
                   <a:srgbClr val="888888"/>
                 </a:solidFill>
               </a:rPr>
-              <a:t>Cancers  ·  Systematic Review</a:t>
+              <a:t>The American journal of case reports  ·  Case Report  ·  🌏 Asia</a:t>
             </a:r>
             <a:endParaRPr lang="en-US" sz="1000" dirty="0"/>
           </a:p>
@@ -5934,7 +5934,7 @@
                   <a:srgbClr val="888888"/>
                 </a:solidFill>
               </a:rPr>
-              <a:t>M Maddula, JE Cohen, D Kumarasinghe. Cancers. 2026</a:t>
+              <a:t>Shimamoto-Nagahira Yoko, Nakanuno Ryuichi. The American journal of case reports. 2026-09-01 DOI: 10.12659/AJCR.953662</a:t>
             </a:r>
             <a:endParaRPr lang="en-US" sz="800" dirty="0"/>
           </a:p>
@@ -6134,7 +6134,7 @@
                   </a:extLst>
                 </a:hlinkClick>
               </a:rPr>
-              <a:t>Neutrophil extracellular traps in colorectal cancer: context-dependent roles from inflammatory carcinogenesis to liver metastasis and therapeutic targeting</a:t>
+              <a:t>Glucosamine Use and Its Association with Colorectal Cancer and Mortality: A Systematic Review and Meta-Analysis</a:t>
             </a:r>
             <a:endParaRPr lang="en-US" sz="2400" dirty="0"/>
           </a:p>
@@ -6170,7 +6170,7 @@
                   <a:srgbClr val="888888"/>
                 </a:solidFill>
               </a:rPr>
-              <a:t>Journal of Translational Medicine  ·  IF 6.1</a:t>
+              <a:t>Journal of Cancer  ·  Meta-Analysis</a:t>
             </a:r>
             <a:endParaRPr lang="en-US" sz="1000" dirty="0"/>
           </a:p>
@@ -6249,7 +6249,7 @@
                   <a:srgbClr val="888888"/>
                 </a:solidFill>
               </a:rPr>
-              <a:t>D Xu, R Wang, J Tan. Journal of Translational Medicine. 2026</a:t>
+              <a:t>Y Yan, M Xu, R Wang. Journal of Cancer. 2026</a:t>
             </a:r>
             <a:endParaRPr lang="en-US" sz="800" dirty="0"/>
           </a:p>

</xml_diff>

<commit_message>
chore: update weekly digest 2026-09-14
</commit_message>
<xml_diff>
--- a/docs/digest-en.pptx
+++ b/docs/digest-en.pptx
@@ -2249,7 +2249,7 @@
                   <a:srgbClr val="888888"/>
                 </a:solidFill>
               </a:rPr>
-              <a:t>2026-08-31 — 2026-09-07</a:t>
+              <a:t>2026-09-07 — 2026-09-14</a:t>
             </a:r>
             <a:endParaRPr lang="en-US" sz="1400" dirty="0"/>
           </a:p>
@@ -2440,7 +2440,7 @@
                   </a:extLst>
                 </a:hlinkClick>
               </a:rPr>
-              <a:t>Prognostic value of systemic immune-inflammation index for colorectal cancer: a systematic review and meta-analysis</a:t>
+              <a:t>Predictive utility of the C-reactive protein-albumin-lymphocyte (CALLY) index in Colorectal cancer: A meta-analysis</a:t>
             </a:r>
             <a:endParaRPr lang="en-US" sz="2400" dirty="0"/>
           </a:p>
@@ -2476,7 +2476,7 @@
                   <a:srgbClr val="888888"/>
                 </a:solidFill>
               </a:rPr>
-              <a:t>Frontiers in Oncology  ·  Meta-Analysis</a:t>
+              <a:t>Clinics and Research in Hepatology and …  ·  Meta-Analysis</a:t>
             </a:r>
             <a:endParaRPr lang="en-US" sz="1000" dirty="0"/>
           </a:p>
@@ -2555,7 +2555,7 @@
                   <a:srgbClr val="888888"/>
                 </a:solidFill>
               </a:rPr>
-              <a:t>P Wang, H Jiang. Frontiers in Oncology. 2026</a:t>
+              <a:t>X Li, T Chu, W Chen. Clinics and Research in Hepatology and …. 2026</a:t>
             </a:r>
             <a:endParaRPr lang="en-US" sz="800" dirty="0"/>
           </a:p>
@@ -2755,7 +2755,7 @@
                   </a:extLst>
                 </a:hlinkClick>
               </a:rPr>
-              <a:t>Peritoneal Metastases in Stage II-III Colon Cancer Represent a Blind Spot for Circulating Tumor DNA Surveillance.</a:t>
+              <a:t>[18F]AlF-FAPI-74 PET/CT for preoperative assessment of the peritoneal cancer index and comparison with MRI-based, surgical and pathological assessment in colorectal cancer patients eligible for CRS-HIPEC: study protocol for a prospective observational proof-of-concept study.</a:t>
             </a:r>
             <a:endParaRPr lang="en-US" sz="2400" dirty="0"/>
           </a:p>
@@ -2791,7 +2791,7 @@
                   <a:srgbClr val="888888"/>
                 </a:solidFill>
               </a:rPr>
-              <a:t>Annals of surgical oncology  ·  IF 3.8  ·  Prospective Study</a:t>
+              <a:t>BMJ open  ·  Prospective Study</a:t>
             </a:r>
             <a:endParaRPr lang="en-US" sz="1000" dirty="0"/>
           </a:p>
@@ -2870,7 +2870,7 @@
                   <a:srgbClr val="888888"/>
                 </a:solidFill>
               </a:rPr>
-              <a:t>Ofori Kwasi Ansere, Smart Huxley, Liu Sean et al.. Annals of surgical oncology. 2026-08-11 DOI: 10.1245/s10434-026-19903-8</a:t>
+              <a:t>van den Bos Myrna, Vogel Wouter V, van Duijvenvoorde Maurice et al.. BMJ open. 2026-09-09 DOI: 10.1136/bmjopen-2026-125722</a:t>
             </a:r>
             <a:endParaRPr lang="en-US" sz="800" dirty="0"/>
           </a:p>
@@ -3070,7 +3070,7 @@
                   </a:extLst>
                 </a:hlinkClick>
               </a:rPr>
-              <a:t>Modulatory role of Blastocystis-derived solubilized antigens in colorectal carcinogenesis: A systematic review.</a:t>
+              <a:t>Multi-omics analysis and experiments reveal an association between polystyrene microplastics exposure and colorectal cancer progression.</a:t>
             </a:r>
             <a:endParaRPr lang="en-US" sz="2400" dirty="0"/>
           </a:p>
@@ -3106,7 +3106,7 @@
                   <a:srgbClr val="888888"/>
                 </a:solidFill>
               </a:rPr>
-              <a:t>Molecular and biochemical parasitology  ·  Systematic Review</a:t>
+              <a:t>Ecotoxicology and environmental safety  ·  Basic Research</a:t>
             </a:r>
             <a:endParaRPr lang="en-US" sz="1000" dirty="0"/>
           </a:p>
@@ -3185,7 +3185,7 @@
                   <a:srgbClr val="888888"/>
                 </a:solidFill>
               </a:rPr>
-              <a:t>Noor Razali Nur Amani Syakirin, Mohd Akmal Nur Anurah Hani, Wardina Mohd Khir Nur Eisya et al.. Molecular and biochemical parasitology. 2026-08-22 DOI: 10.1016/j.molbiopara.2026.111765</a:t>
+              <a:t>Zhang Zheng, Wang Xinyue, Cao Huake et al.. Ecotoxicology and environmental safety. 2026-09-12 DOI: 10.1016/j.ecoenv.2026.120792</a:t>
             </a:r>
             <a:endParaRPr lang="en-US" sz="800" dirty="0"/>
           </a:p>
@@ -3756,7 +3756,7 @@
                 <a:ea typeface="Arial" pitchFamily="34" charset="-122"/>
                 <a:cs typeface="Arial" pitchFamily="34" charset="-120"/>
               </a:rPr>
-              <a:t>Impact of the number of colorectal cancer lymph node metastases on intraperitone…</a:t>
+              <a:t>Integrated clinicogenomic analysis reveals the evolution and metastatic tropisms…</a:t>
             </a:r>
             <a:endParaRPr lang="en-US" sz="1400" dirty="0"/>
           </a:p>
@@ -3793,7 +3793,7 @@
                 <a:ea typeface="Arial" pitchFamily="34" charset="-122"/>
                 <a:cs typeface="Arial" pitchFamily="34" charset="-120"/>
               </a:rPr>
-              <a:t>Troxerutin as a bioactive flavonoid: Insights into its anticancer mechanisms and…</a:t>
+              <a:t>Selective Macrocyclic WEE1 Kinase Inhibitors with Strong Efficacy against Patien…</a:t>
             </a:r>
             <a:endParaRPr lang="en-US" sz="1400" dirty="0"/>
           </a:p>
@@ -3830,7 +3830,7 @@
                 <a:ea typeface="Arial" pitchFamily="34" charset="-122"/>
                 <a:cs typeface="Arial" pitchFamily="34" charset="-120"/>
               </a:rPr>
-              <a:t>Microbiome-Driven Carcinogenesis and Circulating Microbial Signals in Genitourin…</a:t>
+              <a:t>Neoadjuvant chemotherapy and bevacizumab for colorectal peritoneal metastases: c…</a:t>
             </a:r>
             <a:endParaRPr lang="en-US" sz="1400" dirty="0"/>
           </a:p>
@@ -3867,7 +3867,7 @@
                 <a:ea typeface="Arial" pitchFamily="34" charset="-122"/>
                 <a:cs typeface="Arial" pitchFamily="34" charset="-120"/>
               </a:rPr>
-              <a:t>Single-Port Robotic Cytoreductive Surgery for Colon Cancer Peritoneal Recurrence…</a:t>
+              <a:t>Tailoring HIPEC with Patient-Derived Organoids in Colorectal Peritoneal Metastas…</a:t>
             </a:r>
             <a:endParaRPr lang="en-US" sz="1400" dirty="0"/>
           </a:p>
@@ -3904,7 +3904,7 @@
                 <a:ea typeface="Arial" pitchFamily="34" charset="-122"/>
                 <a:cs typeface="Arial" pitchFamily="34" charset="-120"/>
               </a:rPr>
-              <a:t>Body mass index, adjuvant chemotherapy, toxicity, and survival in non-metastatic…</a:t>
+              <a:t>Prophylactic Hyperthermic Intraperitoneal Chemotherapy in Locally Advanced Color…</a:t>
             </a:r>
             <a:endParaRPr lang="en-US" sz="1400" dirty="0"/>
           </a:p>
@@ -3941,7 +3941,7 @@
                 <a:ea typeface="Arial" pitchFamily="34" charset="-122"/>
                 <a:cs typeface="Arial" pitchFamily="34" charset="-120"/>
               </a:rPr>
-              <a:t>Anterior Cutaneous Nerve Entrapment Syndrome in a 51-Year-Old Woman With Advance…</a:t>
+              <a:t>Glucosamine Use and Its Association with Colorectal Cancer and Mortality: A Syst…</a:t>
             </a:r>
             <a:endParaRPr lang="en-US" sz="1400" dirty="0"/>
           </a:p>
@@ -3978,7 +3978,7 @@
                 <a:ea typeface="Arial" pitchFamily="34" charset="-122"/>
                 <a:cs typeface="Arial" pitchFamily="34" charset="-120"/>
               </a:rPr>
-              <a:t>Glucosamine Use and Its Association with Colorectal Cancer and Mortality: A Syst…</a:t>
+              <a:t>Prognostic value of systemic immune-inflammation index for colorectal cancer: a …</a:t>
             </a:r>
             <a:endParaRPr lang="en-US" sz="1400" dirty="0"/>
           </a:p>
@@ -4015,7 +4015,7 @@
                 <a:ea typeface="Arial" pitchFamily="34" charset="-122"/>
                 <a:cs typeface="Arial" pitchFamily="34" charset="-120"/>
               </a:rPr>
-              <a:t>Prognostic value of systemic immune-inflammation index for colorectal cancer: a …</a:t>
+              <a:t>Predictive utility of the C-reactive protein-albumin-lymphocyte (CALLY) index in…</a:t>
             </a:r>
             <a:endParaRPr lang="en-US" sz="1400" dirty="0"/>
           </a:p>
@@ -4052,7 +4052,7 @@
                 <a:ea typeface="Arial" pitchFamily="34" charset="-122"/>
                 <a:cs typeface="Arial" pitchFamily="34" charset="-120"/>
               </a:rPr>
-              <a:t>Peritoneal Metastases in Stage II-III Colon Cancer Represent a Blind Spot for Ci…</a:t>
+              <a:t>[18F]AlF-FAPI-74 PET/CT for preoperative assessment of the peritoneal cancer ind…</a:t>
             </a:r>
             <a:endParaRPr lang="en-US" sz="1400" dirty="0"/>
           </a:p>
@@ -4089,7 +4089,7 @@
                 <a:ea typeface="Arial" pitchFamily="34" charset="-122"/>
                 <a:cs typeface="Arial" pitchFamily="34" charset="-120"/>
               </a:rPr>
-              <a:t>Modulatory role of Blastocystis-derived solubilized antigens in colorectal carci…</a:t>
+              <a:t>Multi-omics analysis and experiments reveal an association between polystyrene m…</a:t>
             </a:r>
             <a:endParaRPr lang="en-US" sz="1400" dirty="0"/>
           </a:p>
@@ -4244,7 +4244,7 @@
                   </a:extLst>
                 </a:hlinkClick>
               </a:rPr>
-              <a:t>Impact of the number of colorectal cancer lymph node metastases on intraperitoneal lavage cytology: a multi-institutional, prospective, observational study.</a:t>
+              <a:t>Integrated clinicogenomic analysis reveals the evolution and metastatic tropisms of advanced colorectal cancer</a:t>
             </a:r>
             <a:endParaRPr lang="en-US" sz="2400" dirty="0"/>
           </a:p>
@@ -4280,7 +4280,7 @@
                   <a:srgbClr val="888888"/>
                 </a:solidFill>
               </a:rPr>
-              <a:t>Surgery today  ·  Prospective Study  ·  🌏 Asia</a:t>
+              <a:t>Cancer Cell  ·  IF 48.8</a:t>
             </a:r>
             <a:endParaRPr lang="en-US" sz="1000" dirty="0"/>
           </a:p>
@@ -4359,7 +4359,7 @@
                   <a:srgbClr val="888888"/>
                 </a:solidFill>
               </a:rPr>
-              <a:t>Mise Minori, Ozawa Heita, Kobayashi Hirotoshi et al.. Surgery today. 2026-08-13 DOI: 10.1007/s00595-026-03313-0</a:t>
+              <a:t>P Manca, H Walch, J Xu. Cancer Cell. 2026</a:t>
             </a:r>
             <a:endParaRPr lang="en-US" sz="800" dirty="0"/>
           </a:p>
@@ -4559,7 +4559,7 @@
                   </a:extLst>
                 </a:hlinkClick>
               </a:rPr>
-              <a:t>Troxerutin as a bioactive flavonoid: Insights into its anticancer mechanisms and therapeutic applications.</a:t>
+              <a:t>Selective Macrocyclic WEE1 Kinase Inhibitors with Strong Efficacy against Patient-Derived Colorectal Cancer Organoids.</a:t>
             </a:r>
             <a:endParaRPr lang="en-US" sz="2400" dirty="0"/>
           </a:p>
@@ -4595,7 +4595,7 @@
                   <a:srgbClr val="888888"/>
                 </a:solidFill>
               </a:rPr>
-              <a:t>European journal of medicinal chemistry  ·  Basic Research  ·  🌏 Asia</a:t>
+              <a:t>Journal of medicinal chemistry  ·  RCT Phase 2</a:t>
             </a:r>
             <a:endParaRPr lang="en-US" sz="1000" dirty="0"/>
           </a:p>
@@ -4674,7 +4674,7 @@
                   <a:srgbClr val="888888"/>
                 </a:solidFill>
               </a:rPr>
-              <a:t>Manna Priya, Chatterjee Srijita, Chatterjee Ganguly Shayeri et al.. European journal of medicinal chemistry. 2026-07-15 DOI: 10.1016/j.ejmech.2026.118885</a:t>
+              <a:t>Syphers Joel L, Wright Josephine A, Kumar Adarsh et al.. Journal of medicinal chemistry. 2026-09-10 DOI: 10.1021/acs.jmedchem.6c00018</a:t>
             </a:r>
             <a:endParaRPr lang="en-US" sz="800" dirty="0"/>
           </a:p>
@@ -4874,7 +4874,7 @@
                   </a:extLst>
                 </a:hlinkClick>
               </a:rPr>
-              <a:t>Microbiome-Driven Carcinogenesis and Circulating Microbial Signals in Genitourinary Cancers.</a:t>
+              <a:t>Neoadjuvant chemotherapy and bevacizumab for colorectal peritoneal metastases: clinical and translational outcomes of the phase II BEV-IP trial</a:t>
             </a:r>
             <a:endParaRPr lang="en-US" sz="2400" dirty="0"/>
           </a:p>
@@ -4910,7 +4910,7 @@
                   <a:srgbClr val="888888"/>
                 </a:solidFill>
               </a:rPr>
-              <a:t>Cancer science  ·  Basic Research  ·  🌏 Asia</a:t>
+              <a:t>Translational …  ·  RCT Phase 2</a:t>
             </a:r>
             <a:endParaRPr lang="en-US" sz="1000" dirty="0"/>
           </a:p>
@@ -4989,7 +4989,7 @@
                   <a:srgbClr val="888888"/>
                 </a:solidFill>
               </a:rPr>
-              <a:t>Kawashima Atsunari, Jingushi Kentaro, Saito Takuro et al.. Cancer science. 2026-09-01 DOI: 10.1111/cas.70448</a:t>
+              <a:t>DKA Chia, J Demuytere, A Hoorens…. Translational …. 2026</a:t>
             </a:r>
             <a:endParaRPr lang="en-US" sz="800" dirty="0"/>
           </a:p>
@@ -5189,7 +5189,7 @@
                   </a:extLst>
                 </a:hlinkClick>
               </a:rPr>
-              <a:t>Single-Port Robotic Cytoreductive Surgery for Colon Cancer Peritoneal Recurrence with the da Vinci SP.</a:t>
+              <a:t>Tailoring HIPEC with Patient-Derived Organoids in Colorectal Peritoneal Metastases: Results from the First Stage of the Prospective Phase II OrganoHIPEC …</a:t>
             </a:r>
             <a:endParaRPr lang="en-US" sz="2400" dirty="0"/>
           </a:p>
@@ -5225,7 +5225,7 @@
                   <a:srgbClr val="888888"/>
                 </a:solidFill>
               </a:rPr>
-              <a:t>Annals of surgical oncology  ·  IF 3.8  ·  Case Report  ·  🌏 Asia</a:t>
+              <a:t>Cancers  ·  RCT Phase 2</a:t>
             </a:r>
             <a:endParaRPr lang="en-US" sz="1000" dirty="0"/>
           </a:p>
@@ -5304,7 +5304,7 @@
                   <a:srgbClr val="888888"/>
                 </a:solidFill>
               </a:rPr>
-              <a:t>Kwon Hoyeon, Park Soo Yeun. Annals of surgical oncology. 2026-08-11 DOI: 10.1245/s10434-026-19743-6</a:t>
+              <a:t>D Baratti, L Varinelli, M Guaglio. Cancers. 2026</a:t>
             </a:r>
             <a:endParaRPr lang="en-US" sz="800" dirty="0"/>
           </a:p>
@@ -5504,7 +5504,7 @@
                   </a:extLst>
                 </a:hlinkClick>
               </a:rPr>
-              <a:t>Body mass index, adjuvant chemotherapy, toxicity, and survival in non-metastatic colorectal cancer: an individual participant data meta-analysis (OCTOPUS).</a:t>
+              <a:t>Prophylactic Hyperthermic Intraperitoneal Chemotherapy in Locally Advanced Colorectal Cancer: Systematic Review and Meta-Analysis</a:t>
             </a:r>
             <a:endParaRPr lang="en-US" sz="2400" dirty="0"/>
           </a:p>
@@ -5540,7 +5540,7 @@
                   <a:srgbClr val="888888"/>
                 </a:solidFill>
               </a:rPr>
-              <a:t>British journal of cancer  ·  IF 6.4  ·  Meta-Analysis</a:t>
+              <a:t>Annals of Surgical …  ·  Meta-Analysis</a:t>
             </a:r>
             <a:endParaRPr lang="en-US" sz="1000" dirty="0"/>
           </a:p>
@@ -5619,7 +5619,7 @@
                   <a:srgbClr val="888888"/>
                 </a:solidFill>
               </a:rPr>
-              <a:t>Slawinski Corinna G V, Malcomson Lee, Barriuso Jorge et al.. British journal of cancer. 2026-08-16 DOI: 10.1038/s41416-026-03472-4</a:t>
+              <a:t>YC Chen, SC Chang, YY Tsai. Annals of Surgical …. 2026</a:t>
             </a:r>
             <a:endParaRPr lang="en-US" sz="800" dirty="0"/>
           </a:p>
@@ -5819,7 +5819,7 @@
                   </a:extLst>
                 </a:hlinkClick>
               </a:rPr>
-              <a:t>Anterior Cutaneous Nerve Entrapment Syndrome in a 51-Year-Old Woman With Advanced Colon Cancer, Successfully Treated With Repeated Ultrasound-Guided Rectus Sheath Blocks: A Case Report.</a:t>
+              <a:t>Glucosamine Use and Its Association with Colorectal Cancer and Mortality: A Systematic Review and Meta-Analysis</a:t>
             </a:r>
             <a:endParaRPr lang="en-US" sz="2400" dirty="0"/>
           </a:p>
@@ -5855,7 +5855,7 @@
                   <a:srgbClr val="888888"/>
                 </a:solidFill>
               </a:rPr>
-              <a:t>The American journal of case reports  ·  Case Report  ·  🌏 Asia</a:t>
+              <a:t>Journal of Cancer  ·  Meta-Analysis</a:t>
             </a:r>
             <a:endParaRPr lang="en-US" sz="1000" dirty="0"/>
           </a:p>
@@ -5934,7 +5934,7 @@
                   <a:srgbClr val="888888"/>
                 </a:solidFill>
               </a:rPr>
-              <a:t>Shimamoto-Nagahira Yoko, Nakanuno Ryuichi. The American journal of case reports. 2026-09-01 DOI: 10.12659/AJCR.953662</a:t>
+              <a:t>Y Yan, M Xu, R Wang. Journal of Cancer. 2026</a:t>
             </a:r>
             <a:endParaRPr lang="en-US" sz="800" dirty="0"/>
           </a:p>
@@ -6134,7 +6134,7 @@
                   </a:extLst>
                 </a:hlinkClick>
               </a:rPr>
-              <a:t>Glucosamine Use and Its Association with Colorectal Cancer and Mortality: A Systematic Review and Meta-Analysis</a:t>
+              <a:t>Prognostic value of systemic immune-inflammation index for colorectal cancer: a systematic review and meta-analysis</a:t>
             </a:r>
             <a:endParaRPr lang="en-US" sz="2400" dirty="0"/>
           </a:p>
@@ -6170,7 +6170,7 @@
                   <a:srgbClr val="888888"/>
                 </a:solidFill>
               </a:rPr>
-              <a:t>Journal of Cancer  ·  Meta-Analysis</a:t>
+              <a:t>Frontiers in Oncology  ·  Meta-Analysis</a:t>
             </a:r>
             <a:endParaRPr lang="en-US" sz="1000" dirty="0"/>
           </a:p>
@@ -6249,7 +6249,7 @@
                   <a:srgbClr val="888888"/>
                 </a:solidFill>
               </a:rPr>
-              <a:t>Y Yan, M Xu, R Wang. Journal of Cancer. 2026</a:t>
+              <a:t>P Wang, H Jiang. Frontiers in Oncology. 2026</a:t>
             </a:r>
             <a:endParaRPr lang="en-US" sz="800" dirty="0"/>
           </a:p>

</xml_diff>

<commit_message>
chore: update weekly digest 2026-09-21
</commit_message>
<xml_diff>
--- a/docs/digest-en.pptx
+++ b/docs/digest-en.pptx
@@ -2249,7 +2249,7 @@
                   <a:srgbClr val="888888"/>
                 </a:solidFill>
               </a:rPr>
-              <a:t>2026-09-07 — 2026-09-14</a:t>
+              <a:t>2026-09-14 — 2026-09-21</a:t>
             </a:r>
             <a:endParaRPr lang="en-US" sz="1400" dirty="0"/>
           </a:p>
@@ -2440,7 +2440,7 @@
                   </a:extLst>
                 </a:hlinkClick>
               </a:rPr>
-              <a:t>Predictive utility of the C-reactive protein-albumin-lymphocyte (CALLY) index in Colorectal cancer: A meta-analysis</a:t>
+              <a:t>Self-rolling film for in vivo drug delivery to limit colonic inflammation induced after radiation exposure.</a:t>
             </a:r>
             <a:endParaRPr lang="en-US" sz="2400" dirty="0"/>
           </a:p>
@@ -2476,7 +2476,7 @@
                   <a:srgbClr val="888888"/>
                 </a:solidFill>
               </a:rPr>
-              <a:t>Clinics and Research in Hepatology and …  ·  Meta-Analysis</a:t>
+              <a:t>iScience  ·  Basic Research</a:t>
             </a:r>
             <a:endParaRPr lang="en-US" sz="1000" dirty="0"/>
           </a:p>
@@ -2555,7 +2555,7 @@
                   <a:srgbClr val="888888"/>
                 </a:solidFill>
               </a:rPr>
-              <a:t>X Li, T Chu, W Chen. Clinics and Research in Hepatology and …. 2026</a:t>
+              <a:t>Amarante-Silva Diego, Demarquay Christelle, Nottelet Benjamin et al.. iScience. 2026-09-14 DOI: 10.1016/j.isci.2026.117453</a:t>
             </a:r>
             <a:endParaRPr lang="en-US" sz="800" dirty="0"/>
           </a:p>
@@ -2755,7 +2755,7 @@
                   </a:extLst>
                 </a:hlinkClick>
               </a:rPr>
-              <a:t>[18F]AlF-FAPI-74 PET/CT for preoperative assessment of the peritoneal cancer index and comparison with MRI-based, surgical and pathological assessment in colorectal cancer patients eligible for CRS-HIPEC: study protocol for a prospective observational proof-of-concept study.</a:t>
+              <a:t>Twin-Drink Endogastric-Forming Hydrogel for Multimodal Colitis-Associated Colorectal Cancer Management.</a:t>
             </a:r>
             <a:endParaRPr lang="en-US" sz="2400" dirty="0"/>
           </a:p>
@@ -2791,7 +2791,7 @@
                   <a:srgbClr val="888888"/>
                 </a:solidFill>
               </a:rPr>
-              <a:t>BMJ open  ·  Prospective Study</a:t>
+              <a:t>Advanced materials (Deerfield Beach, Fla.)  ·  Basic Research</a:t>
             </a:r>
             <a:endParaRPr lang="en-US" sz="1000" dirty="0"/>
           </a:p>
@@ -2870,7 +2870,7 @@
                   <a:srgbClr val="888888"/>
                 </a:solidFill>
               </a:rPr>
-              <a:t>van den Bos Myrna, Vogel Wouter V, van Duijvenvoorde Maurice et al.. BMJ open. 2026-09-09 DOI: 10.1136/bmjopen-2026-125722</a:t>
+              <a:t>Feng Yuzhao, Meng Ran, Luo Kai et al.. Advanced materials (Deerfield Beach, Fla.). 2026-09-18 DOI: 10.1002/adma.75037</a:t>
             </a:r>
             <a:endParaRPr lang="en-US" sz="800" dirty="0"/>
           </a:p>
@@ -3070,7 +3070,7 @@
                   </a:extLst>
                 </a:hlinkClick>
               </a:rPr>
-              <a:t>Multi-omics analysis and experiments reveal an association between polystyrene microplastics exposure and colorectal cancer progression.</a:t>
+              <a:t>The role of mTORC2/RICTOR in immune cells and inflammatory diseases.</a:t>
             </a:r>
             <a:endParaRPr lang="en-US" sz="2400" dirty="0"/>
           </a:p>
@@ -3106,7 +3106,7 @@
                   <a:srgbClr val="888888"/>
                 </a:solidFill>
               </a:rPr>
-              <a:t>Ecotoxicology and environmental safety  ·  Basic Research</a:t>
+              <a:t>Inflammation research : official journal of the European Histamine Research Society ... [et al.]  ·  Basic Research</a:t>
             </a:r>
             <a:endParaRPr lang="en-US" sz="1000" dirty="0"/>
           </a:p>
@@ -3185,7 +3185,7 @@
                   <a:srgbClr val="888888"/>
                 </a:solidFill>
               </a:rPr>
-              <a:t>Zhang Zheng, Wang Xinyue, Cao Huake et al.. Ecotoxicology and environmental safety. 2026-09-12 DOI: 10.1016/j.ecoenv.2026.120792</a:t>
+              <a:t>Xu Jingting, Zhong Wenxin, Xin Fei et al.. Inflammation research : official journal of the European Histamine Research Society ... [et al.]. 2026-09-17 DOI: 10.1007/s00011-026-02365-9</a:t>
             </a:r>
             <a:endParaRPr lang="en-US" sz="800" dirty="0"/>
           </a:p>
@@ -3756,7 +3756,7 @@
                 <a:ea typeface="Arial" pitchFamily="34" charset="-122"/>
                 <a:cs typeface="Arial" pitchFamily="34" charset="-120"/>
               </a:rPr>
-              <a:t>Integrated clinicogenomic analysis reveals the evolution and metastatic tropisms…</a:t>
+              <a:t>Zearalenone exposure is associated with increased tumor burden and coordinated h…</a:t>
             </a:r>
             <a:endParaRPr lang="en-US" sz="1400" dirty="0"/>
           </a:p>
@@ -3793,7 +3793,7 @@
                 <a:ea typeface="Arial" pitchFamily="34" charset="-122"/>
                 <a:cs typeface="Arial" pitchFamily="34" charset="-120"/>
               </a:rPr>
-              <a:t>Selective Macrocyclic WEE1 Kinase Inhibitors with Strong Efficacy against Patien…</a:t>
+              <a:t>Non-canonical Wnt11/PCP/YAP signaling mediates epithelial-mesenchymal transition…</a:t>
             </a:r>
             <a:endParaRPr lang="en-US" sz="1400" dirty="0"/>
           </a:p>
@@ -3830,7 +3830,7 @@
                 <a:ea typeface="Arial" pitchFamily="34" charset="-122"/>
                 <a:cs typeface="Arial" pitchFamily="34" charset="-120"/>
               </a:rPr>
-              <a:t>Neoadjuvant chemotherapy and bevacizumab for colorectal peritoneal metastases: c…</a:t>
+              <a:t>Prognostic value of systemic immune-inflammation index for colorectal cancer: a …</a:t>
             </a:r>
             <a:endParaRPr lang="en-US" sz="1400" dirty="0"/>
           </a:p>
@@ -3867,7 +3867,7 @@
                 <a:ea typeface="Arial" pitchFamily="34" charset="-122"/>
                 <a:cs typeface="Arial" pitchFamily="34" charset="-120"/>
               </a:rPr>
-              <a:t>Tailoring HIPEC with Patient-Derived Organoids in Colorectal Peritoneal Metastas…</a:t>
+              <a:t>Predictive utility of the C-reactive protein-albumin-lymphocyte (CALLY) index in…</a:t>
             </a:r>
             <a:endParaRPr lang="en-US" sz="1400" dirty="0"/>
           </a:p>
@@ -3904,7 +3904,7 @@
                 <a:ea typeface="Arial" pitchFamily="34" charset="-122"/>
                 <a:cs typeface="Arial" pitchFamily="34" charset="-120"/>
               </a:rPr>
-              <a:t>Prophylactic Hyperthermic Intraperitoneal Chemotherapy in Locally Advanced Color…</a:t>
+              <a:t>Magnetothermal Wax Capsule for Localized Gastrointestinal Drug Delivery.</a:t>
             </a:r>
             <a:endParaRPr lang="en-US" sz="1400" dirty="0"/>
           </a:p>
@@ -3941,7 +3941,7 @@
                 <a:ea typeface="Arial" pitchFamily="34" charset="-122"/>
                 <a:cs typeface="Arial" pitchFamily="34" charset="-120"/>
               </a:rPr>
-              <a:t>Glucosamine Use and Its Association with Colorectal Cancer and Mortality: A Syst…</a:t>
+              <a:t>Batri-7 Attenuates Established Inflammation-Associated Colorectal Adenoma via PI…</a:t>
             </a:r>
             <a:endParaRPr lang="en-US" sz="1400" dirty="0"/>
           </a:p>
@@ -3978,7 +3978,7 @@
                 <a:ea typeface="Arial" pitchFamily="34" charset="-122"/>
                 <a:cs typeface="Arial" pitchFamily="34" charset="-120"/>
               </a:rPr>
-              <a:t>Prognostic value of systemic immune-inflammation index for colorectal cancer: a …</a:t>
+              <a:t>Shaoyao Decoction Inhibits Colorectal Cancer Progression by Targeting PD-L1 to R…</a:t>
             </a:r>
             <a:endParaRPr lang="en-US" sz="1400" dirty="0"/>
           </a:p>
@@ -4015,7 +4015,7 @@
                 <a:ea typeface="Arial" pitchFamily="34" charset="-122"/>
                 <a:cs typeface="Arial" pitchFamily="34" charset="-120"/>
               </a:rPr>
-              <a:t>Predictive utility of the C-reactive protein-albumin-lymphocyte (CALLY) index in…</a:t>
+              <a:t>Self-rolling film for in vivo drug delivery to limit colonic inflammation induce…</a:t>
             </a:r>
             <a:endParaRPr lang="en-US" sz="1400" dirty="0"/>
           </a:p>
@@ -4052,7 +4052,7 @@
                 <a:ea typeface="Arial" pitchFamily="34" charset="-122"/>
                 <a:cs typeface="Arial" pitchFamily="34" charset="-120"/>
               </a:rPr>
-              <a:t>[18F]AlF-FAPI-74 PET/CT for preoperative assessment of the peritoneal cancer ind…</a:t>
+              <a:t>Twin-Drink Endogastric-Forming Hydrogel for Multimodal Colitis-Associated Colore…</a:t>
             </a:r>
             <a:endParaRPr lang="en-US" sz="1400" dirty="0"/>
           </a:p>
@@ -4089,7 +4089,7 @@
                 <a:ea typeface="Arial" pitchFamily="34" charset="-122"/>
                 <a:cs typeface="Arial" pitchFamily="34" charset="-120"/>
               </a:rPr>
-              <a:t>Multi-omics analysis and experiments reveal an association between polystyrene m…</a:t>
+              <a:t>The role of mTORC2/RICTOR in immune cells and inflammatory diseases.</a:t>
             </a:r>
             <a:endParaRPr lang="en-US" sz="1400" dirty="0"/>
           </a:p>
@@ -4244,7 +4244,7 @@
                   </a:extLst>
                 </a:hlinkClick>
               </a:rPr>
-              <a:t>Integrated clinicogenomic analysis reveals the evolution and metastatic tropisms of advanced colorectal cancer</a:t>
+              <a:t>Zearalenone exposure is associated with increased tumor burden and coordinated host-microbiota-metabolic alterations in colitis-associated colorectal cancer.</a:t>
             </a:r>
             <a:endParaRPr lang="en-US" sz="2400" dirty="0"/>
           </a:p>
@@ -4280,7 +4280,7 @@
                   <a:srgbClr val="888888"/>
                 </a:solidFill>
               </a:rPr>
-              <a:t>Cancer Cell  ·  IF 48.8</a:t>
+              <a:t>Ecotoxicology and environmental safety  ·  Basic Research  ·  🌏 Asia</a:t>
             </a:r>
             <a:endParaRPr lang="en-US" sz="1000" dirty="0"/>
           </a:p>
@@ -4359,7 +4359,7 @@
                   <a:srgbClr val="888888"/>
                 </a:solidFill>
               </a:rPr>
-              <a:t>P Manca, H Walch, J Xu. Cancer Cell. 2026</a:t>
+              <a:t>Wu Kun, Wang Jiaqi, Gao Xinyi et al.. Ecotoxicology and environmental safety. 2026-09-19 DOI: 10.1016/j.ecoenv.2026.120811</a:t>
             </a:r>
             <a:endParaRPr lang="en-US" sz="800" dirty="0"/>
           </a:p>
@@ -4559,7 +4559,7 @@
                   </a:extLst>
                 </a:hlinkClick>
               </a:rPr>
-              <a:t>Selective Macrocyclic WEE1 Kinase Inhibitors with Strong Efficacy against Patient-Derived Colorectal Cancer Organoids.</a:t>
+              <a:t>Non-canonical Wnt11/PCP/YAP signaling mediates epithelial-mesenchymal transition and immunosuppressive tumor microenvironment in colorectal cancer.</a:t>
             </a:r>
             <a:endParaRPr lang="en-US" sz="2400" dirty="0"/>
           </a:p>
@@ -4595,7 +4595,7 @@
                   <a:srgbClr val="888888"/>
                 </a:solidFill>
               </a:rPr>
-              <a:t>Journal of medicinal chemistry  ·  RCT Phase 2</a:t>
+              <a:t>International immunopharmacology  ·  Basic Research  ·  🌏 Asia</a:t>
             </a:r>
             <a:endParaRPr lang="en-US" sz="1000" dirty="0"/>
           </a:p>
@@ -4674,7 +4674,7 @@
                   <a:srgbClr val="888888"/>
                 </a:solidFill>
               </a:rPr>
-              <a:t>Syphers Joel L, Wright Josephine A, Kumar Adarsh et al.. Journal of medicinal chemistry. 2026-09-10 DOI: 10.1021/acs.jmedchem.6c00018</a:t>
+              <a:t>Wang Shibao, Cai Hengyu, Dai Enyong et al.. International immunopharmacology. 2026-09-18 DOI: 10.1016/j.intimp.2026.117408</a:t>
             </a:r>
             <a:endParaRPr lang="en-US" sz="800" dirty="0"/>
           </a:p>
@@ -4874,7 +4874,7 @@
                   </a:extLst>
                 </a:hlinkClick>
               </a:rPr>
-              <a:t>Neoadjuvant chemotherapy and bevacizumab for colorectal peritoneal metastases: clinical and translational outcomes of the phase II BEV-IP trial</a:t>
+              <a:t>Prognostic value of systemic immune-inflammation index for colorectal cancer: a systematic review and meta-analysis</a:t>
             </a:r>
             <a:endParaRPr lang="en-US" sz="2400" dirty="0"/>
           </a:p>
@@ -4910,7 +4910,7 @@
                   <a:srgbClr val="888888"/>
                 </a:solidFill>
               </a:rPr>
-              <a:t>Translational …  ·  RCT Phase 2</a:t>
+              <a:t>Frontiers in Oncology  ·  Meta-Analysis</a:t>
             </a:r>
             <a:endParaRPr lang="en-US" sz="1000" dirty="0"/>
           </a:p>
@@ -4989,7 +4989,7 @@
                   <a:srgbClr val="888888"/>
                 </a:solidFill>
               </a:rPr>
-              <a:t>DKA Chia, J Demuytere, A Hoorens…. Translational …. 2026</a:t>
+              <a:t>P Wang, H Jiang. Frontiers in Oncology. 2026</a:t>
             </a:r>
             <a:endParaRPr lang="en-US" sz="800" dirty="0"/>
           </a:p>
@@ -5189,7 +5189,7 @@
                   </a:extLst>
                 </a:hlinkClick>
               </a:rPr>
-              <a:t>Tailoring HIPEC with Patient-Derived Organoids in Colorectal Peritoneal Metastases: Results from the First Stage of the Prospective Phase II OrganoHIPEC …</a:t>
+              <a:t>Predictive utility of the C-reactive protein-albumin-lymphocyte (CALLY) index in Colorectal cancer: A meta-analysis</a:t>
             </a:r>
             <a:endParaRPr lang="en-US" sz="2400" dirty="0"/>
           </a:p>
@@ -5225,7 +5225,7 @@
                   <a:srgbClr val="888888"/>
                 </a:solidFill>
               </a:rPr>
-              <a:t>Cancers  ·  RCT Phase 2</a:t>
+              <a:t>Clinics and Research in Hepatology and …  ·  Meta-Analysis</a:t>
             </a:r>
             <a:endParaRPr lang="en-US" sz="1000" dirty="0"/>
           </a:p>
@@ -5304,7 +5304,7 @@
                   <a:srgbClr val="888888"/>
                 </a:solidFill>
               </a:rPr>
-              <a:t>D Baratti, L Varinelli, M Guaglio. Cancers. 2026</a:t>
+              <a:t>X Li, T Chu, W Chen. Clinics and Research in Hepatology and …. 2026</a:t>
             </a:r>
             <a:endParaRPr lang="en-US" sz="800" dirty="0"/>
           </a:p>
@@ -5504,7 +5504,7 @@
                   </a:extLst>
                 </a:hlinkClick>
               </a:rPr>
-              <a:t>Prophylactic Hyperthermic Intraperitoneal Chemotherapy in Locally Advanced Colorectal Cancer: Systematic Review and Meta-Analysis</a:t>
+              <a:t>Magnetothermal Wax Capsule for Localized Gastrointestinal Drug Delivery.</a:t>
             </a:r>
             <a:endParaRPr lang="en-US" sz="2400" dirty="0"/>
           </a:p>
@@ -5540,7 +5540,7 @@
                   <a:srgbClr val="888888"/>
                 </a:solidFill>
               </a:rPr>
-              <a:t>Annals of Surgical …  ·  Meta-Analysis</a:t>
+              <a:t>ACS applied bio materials  ·  Basic Research</a:t>
             </a:r>
             <a:endParaRPr lang="en-US" sz="1000" dirty="0"/>
           </a:p>
@@ -5619,7 +5619,7 @@
                   <a:srgbClr val="888888"/>
                 </a:solidFill>
               </a:rPr>
-              <a:t>YC Chen, SC Chang, YY Tsai. Annals of Surgical …. 2026</a:t>
+              <a:t>Zhang Yuming, Zhang Kai, Juriga-T&amp;#xf3;th Krisztina et al.. ACS applied bio materials. 2026-09-19 DOI: 10.1021/acsabm.6c01141</a:t>
             </a:r>
             <a:endParaRPr lang="en-US" sz="800" dirty="0"/>
           </a:p>
@@ -5819,7 +5819,7 @@
                   </a:extLst>
                 </a:hlinkClick>
               </a:rPr>
-              <a:t>Glucosamine Use and Its Association with Colorectal Cancer and Mortality: A Systematic Review and Meta-Analysis</a:t>
+              <a:t>Batri-7 Attenuates Established Inflammation-Associated Colorectal Adenoma via PI3K/AKT Inhibition and BAX-Associated Apoptosis.</a:t>
             </a:r>
             <a:endParaRPr lang="en-US" sz="2400" dirty="0"/>
           </a:p>
@@ -5855,7 +5855,7 @@
                   <a:srgbClr val="888888"/>
                 </a:solidFill>
               </a:rPr>
-              <a:t>Journal of Cancer  ·  Meta-Analysis</a:t>
+              <a:t>Journal of ethnopharmacology  ·  Basic Research</a:t>
             </a:r>
             <a:endParaRPr lang="en-US" sz="1000" dirty="0"/>
           </a:p>
@@ -5934,7 +5934,7 @@
                   <a:srgbClr val="888888"/>
                 </a:solidFill>
               </a:rPr>
-              <a:t>Y Yan, M Xu, R Wang. Journal of Cancer. 2026</a:t>
+              <a:t>Yang Zhiqing, Liu Fangyuan, Sun Xuemeng et al.. Journal of ethnopharmacology. 2026-09-18 DOI: 10.1016/j.jep.2026.122368</a:t>
             </a:r>
             <a:endParaRPr lang="en-US" sz="800" dirty="0"/>
           </a:p>
@@ -6134,7 +6134,7 @@
                   </a:extLst>
                 </a:hlinkClick>
               </a:rPr>
-              <a:t>Prognostic value of systemic immune-inflammation index for colorectal cancer: a systematic review and meta-analysis</a:t>
+              <a:t>Shaoyao Decoction Inhibits Colorectal Cancer Progression by Targeting PD-L1 to Reprogram the Immunosuppressive Tumor Microenvironment.</a:t>
             </a:r>
             <a:endParaRPr lang="en-US" sz="2400" dirty="0"/>
           </a:p>
@@ -6170,7 +6170,7 @@
                   <a:srgbClr val="888888"/>
                 </a:solidFill>
               </a:rPr>
-              <a:t>Frontiers in Oncology  ·  Meta-Analysis</a:t>
+              <a:t>Applied biochemistry and biotechnology  ·  Basic Research</a:t>
             </a:r>
             <a:endParaRPr lang="en-US" sz="1000" dirty="0"/>
           </a:p>
@@ -6249,7 +6249,7 @@
                   <a:srgbClr val="888888"/>
                 </a:solidFill>
               </a:rPr>
-              <a:t>P Wang, H Jiang. Frontiers in Oncology. 2026</a:t>
+              <a:t>Wang Xiaoyan, Mima Zhuoga, Sai Wujie et al.. Applied biochemistry and biotechnology. 2026-09-18 DOI: 10.1007/s12010-026-05926-0</a:t>
             </a:r>
             <a:endParaRPr lang="en-US" sz="800" dirty="0"/>
           </a:p>

</xml_diff>

<commit_message>
chore: update weekly digest 2026-09-28
</commit_message>
<xml_diff>
--- a/docs/digest-en.pptx
+++ b/docs/digest-en.pptx
@@ -2249,7 +2249,7 @@
                   <a:srgbClr val="888888"/>
                 </a:solidFill>
               </a:rPr>
-              <a:t>2026-09-14 — 2026-09-21</a:t>
+              <a:t>2026-09-21 — 2026-09-28</a:t>
             </a:r>
             <a:endParaRPr lang="en-US" sz="1400" dirty="0"/>
           </a:p>
@@ -2440,7 +2440,7 @@
                   </a:extLst>
                 </a:hlinkClick>
               </a:rPr>
-              <a:t>Self-rolling film for in vivo drug delivery to limit colonic inflammation induced after radiation exposure.</a:t>
+              <a:t>The barrier–microbiota–inflammation axis in colorectal cancer: Mechanisms and emerging diagnostic &amp; therapeutic strategies</a:t>
             </a:r>
             <a:endParaRPr lang="en-US" sz="2400" dirty="0"/>
           </a:p>
@@ -2476,7 +2476,7 @@
                   <a:srgbClr val="888888"/>
                 </a:solidFill>
               </a:rPr>
-              <a:t>iScience  ·  Basic Research</a:t>
+              <a:t>Cancers  ·  Basic Research</a:t>
             </a:r>
             <a:endParaRPr lang="en-US" sz="1000" dirty="0"/>
           </a:p>
@@ -2555,7 +2555,7 @@
                   <a:srgbClr val="888888"/>
                 </a:solidFill>
               </a:rPr>
-              <a:t>Amarante-Silva Diego, Demarquay Christelle, Nottelet Benjamin et al.. iScience. 2026-09-14 DOI: 10.1016/j.isci.2026.117453</a:t>
+              <a:t>X Dong, J Yang, L He. Cancers. 2026</a:t>
             </a:r>
             <a:endParaRPr lang="en-US" sz="800" dirty="0"/>
           </a:p>
@@ -2755,7 +2755,7 @@
                   </a:extLst>
                 </a:hlinkClick>
               </a:rPr>
-              <a:t>Twin-Drink Endogastric-Forming Hydrogel for Multimodal Colitis-Associated Colorectal Cancer Management.</a:t>
+              <a:t>Site-dependent Treg cell transcriptional reprogramming in a metastatic colorectal cancer model holds prognostic significance.</a:t>
             </a:r>
             <a:endParaRPr lang="en-US" sz="2400" dirty="0"/>
           </a:p>
@@ -2791,7 +2791,7 @@
                   <a:srgbClr val="888888"/>
                 </a:solidFill>
               </a:rPr>
-              <a:t>Advanced materials (Deerfield Beach, Fla.)  ·  Basic Research</a:t>
+              <a:t>Cancer letters</a:t>
             </a:r>
             <a:endParaRPr lang="en-US" sz="1000" dirty="0"/>
           </a:p>
@@ -2870,7 +2870,7 @@
                   <a:srgbClr val="888888"/>
                 </a:solidFill>
               </a:rPr>
-              <a:t>Feng Yuzhao, Meng Ran, Luo Kai et al.. Advanced materials (Deerfield Beach, Fla.). 2026-09-18 DOI: 10.1002/adma.75037</a:t>
+              <a:t>Aristin Revilla Sonia, Verheem Andre, Frederiks Cynthia Lisanne et al.. Cancer letters. 2026-07-08 DOI: 10.1016/j.canlet.2026.218656</a:t>
             </a:r>
             <a:endParaRPr lang="en-US" sz="800" dirty="0"/>
           </a:p>
@@ -3070,7 +3070,7 @@
                   </a:extLst>
                 </a:hlinkClick>
               </a:rPr>
-              <a:t>The role of mTORC2/RICTOR in immune cells and inflammatory diseases.</a:t>
+              <a:t>Consensus Guideline for the Management of Colorectal Cancer with Peritoneal Metastases: PSM Writing Group et al.</a:t>
             </a:r>
             <a:endParaRPr lang="en-US" sz="2400" dirty="0"/>
           </a:p>
@@ -3106,7 +3106,7 @@
                   <a:srgbClr val="888888"/>
                 </a:solidFill>
               </a:rPr>
-              <a:t>Inflammation research : official journal of the European Histamine Research Society ... [et al.]  ·  Basic Research</a:t>
+              <a:t>Annals of surgical …</a:t>
             </a:r>
             <a:endParaRPr lang="en-US" sz="1000" dirty="0"/>
           </a:p>
@@ -3185,7 +3185,7 @@
                   <a:srgbClr val="888888"/>
                 </a:solidFill>
               </a:rPr>
-              <a:t>Xu Jingting, Zhong Wenxin, Xin Fei et al.. Inflammation research : official journal of the European Histamine Research Society ... [et al.]. 2026-09-17 DOI: 10.1007/s00011-026-02365-9</a:t>
+              <a:t>KS Schultz, VV Bansal, MM Wach. Annals of surgical …. 2026</a:t>
             </a:r>
             <a:endParaRPr lang="en-US" sz="800" dirty="0"/>
           </a:p>
@@ -3756,7 +3756,7 @@
                 <a:ea typeface="Arial" pitchFamily="34" charset="-122"/>
                 <a:cs typeface="Arial" pitchFamily="34" charset="-120"/>
               </a:rPr>
-              <a:t>Zearalenone exposure is associated with increased tumor burden and coordinated h…</a:t>
+              <a:t>Prognostic value of systemic immune-inflammation index for colorectal cancer: a …</a:t>
             </a:r>
             <a:endParaRPr lang="en-US" sz="1400" dirty="0"/>
           </a:p>
@@ -3793,7 +3793,7 @@
                 <a:ea typeface="Arial" pitchFamily="34" charset="-122"/>
                 <a:cs typeface="Arial" pitchFamily="34" charset="-120"/>
               </a:rPr>
-              <a:t>Non-canonical Wnt11/PCP/YAP signaling mediates epithelial-mesenchymal transition…</a:t>
+              <a:t>Predictive utility of the C-reactive protein-albumin-lymphocyte (CALLY) index in…</a:t>
             </a:r>
             <a:endParaRPr lang="en-US" sz="1400" dirty="0"/>
           </a:p>
@@ -3830,7 +3830,7 @@
                 <a:ea typeface="Arial" pitchFamily="34" charset="-122"/>
                 <a:cs typeface="Arial" pitchFamily="34" charset="-120"/>
               </a:rPr>
-              <a:t>Prognostic value of systemic immune-inflammation index for colorectal cancer: a …</a:t>
+              <a:t>Fatty Acid Heterogeneity in Colorectal Cancer: From Food Matrices to Targeted In…</a:t>
             </a:r>
             <a:endParaRPr lang="en-US" sz="1400" dirty="0"/>
           </a:p>
@@ -3867,7 +3867,7 @@
                 <a:ea typeface="Arial" pitchFamily="34" charset="-122"/>
                 <a:cs typeface="Arial" pitchFamily="34" charset="-120"/>
               </a:rPr>
-              <a:t>Predictive utility of the C-reactive protein-albumin-lymphocyte (CALLY) index in…</a:t>
+              <a:t>Multi-omic profiling identifies TREM2+ lipid-laden macrophages as inflammatory d…</a:t>
             </a:r>
             <a:endParaRPr lang="en-US" sz="1400" dirty="0"/>
           </a:p>
@@ -3904,7 +3904,7 @@
                 <a:ea typeface="Arial" pitchFamily="34" charset="-122"/>
                 <a:cs typeface="Arial" pitchFamily="34" charset="-120"/>
               </a:rPr>
-              <a:t>Magnetothermal Wax Capsule for Localized Gastrointestinal Drug Delivery.</a:t>
+              <a:t>Vesicular QSOX1-MMP2 from inflammatory cancer-associated fibroblasts degrades th…</a:t>
             </a:r>
             <a:endParaRPr lang="en-US" sz="1400" dirty="0"/>
           </a:p>
@@ -3941,7 +3941,7 @@
                 <a:ea typeface="Arial" pitchFamily="34" charset="-122"/>
                 <a:cs typeface="Arial" pitchFamily="34" charset="-120"/>
               </a:rPr>
-              <a:t>Batri-7 Attenuates Established Inflammation-Associated Colorectal Adenoma via PI…</a:t>
+              <a:t>Targeted Colorectal Cancer Therapy Using Cabozantinib-Loaded PLGA Nanoparticles:…</a:t>
             </a:r>
             <a:endParaRPr lang="en-US" sz="1400" dirty="0"/>
           </a:p>
@@ -3978,7 +3978,7 @@
                 <a:ea typeface="Arial" pitchFamily="34" charset="-122"/>
                 <a:cs typeface="Arial" pitchFamily="34" charset="-120"/>
               </a:rPr>
-              <a:t>Shaoyao Decoction Inhibits Colorectal Cancer Progression by Targeting PD-L1 to R…</a:t>
+              <a:t>A novel human Streptomyces strain redresses malignancy by inducing apoptosis and…</a:t>
             </a:r>
             <a:endParaRPr lang="en-US" sz="1400" dirty="0"/>
           </a:p>
@@ -4015,7 +4015,7 @@
                 <a:ea typeface="Arial" pitchFamily="34" charset="-122"/>
                 <a:cs typeface="Arial" pitchFamily="34" charset="-120"/>
               </a:rPr>
-              <a:t>Self-rolling film for in vivo drug delivery to limit colonic inflammation induce…</a:t>
+              <a:t>The barrier–microbiota–inflammation axis in colorectal cancer: Mechanisms and em…</a:t>
             </a:r>
             <a:endParaRPr lang="en-US" sz="1400" dirty="0"/>
           </a:p>
@@ -4052,7 +4052,7 @@
                 <a:ea typeface="Arial" pitchFamily="34" charset="-122"/>
                 <a:cs typeface="Arial" pitchFamily="34" charset="-120"/>
               </a:rPr>
-              <a:t>Twin-Drink Endogastric-Forming Hydrogel for Multimodal Colitis-Associated Colore…</a:t>
+              <a:t>Site-dependent Treg cell transcriptional reprogramming in a metastatic colorecta…</a:t>
             </a:r>
             <a:endParaRPr lang="en-US" sz="1400" dirty="0"/>
           </a:p>
@@ -4089,7 +4089,7 @@
                 <a:ea typeface="Arial" pitchFamily="34" charset="-122"/>
                 <a:cs typeface="Arial" pitchFamily="34" charset="-120"/>
               </a:rPr>
-              <a:t>The role of mTORC2/RICTOR in immune cells and inflammatory diseases.</a:t>
+              <a:t>Consensus Guideline for the Management of Colorectal Cancer with Peritoneal Meta…</a:t>
             </a:r>
             <a:endParaRPr lang="en-US" sz="1400" dirty="0"/>
           </a:p>
@@ -4244,7 +4244,7 @@
                   </a:extLst>
                 </a:hlinkClick>
               </a:rPr>
-              <a:t>Zearalenone exposure is associated with increased tumor burden and coordinated host-microbiota-metabolic alterations in colitis-associated colorectal cancer.</a:t>
+              <a:t>Prognostic value of systemic immune-inflammation index for colorectal cancer: a systematic review and meta-analysis</a:t>
             </a:r>
             <a:endParaRPr lang="en-US" sz="2400" dirty="0"/>
           </a:p>
@@ -4280,7 +4280,7 @@
                   <a:srgbClr val="888888"/>
                 </a:solidFill>
               </a:rPr>
-              <a:t>Ecotoxicology and environmental safety  ·  Basic Research  ·  🌏 Asia</a:t>
+              <a:t>Frontiers in Oncology  ·  Meta-Analysis</a:t>
             </a:r>
             <a:endParaRPr lang="en-US" sz="1000" dirty="0"/>
           </a:p>
@@ -4359,7 +4359,7 @@
                   <a:srgbClr val="888888"/>
                 </a:solidFill>
               </a:rPr>
-              <a:t>Wu Kun, Wang Jiaqi, Gao Xinyi et al.. Ecotoxicology and environmental safety. 2026-09-19 DOI: 10.1016/j.ecoenv.2026.120811</a:t>
+              <a:t>P Wang, H Jiang. Frontiers in Oncology. 2026</a:t>
             </a:r>
             <a:endParaRPr lang="en-US" sz="800" dirty="0"/>
           </a:p>
@@ -4559,7 +4559,7 @@
                   </a:extLst>
                 </a:hlinkClick>
               </a:rPr>
-              <a:t>Non-canonical Wnt11/PCP/YAP signaling mediates epithelial-mesenchymal transition and immunosuppressive tumor microenvironment in colorectal cancer.</a:t>
+              <a:t>Predictive utility of the C-reactive protein-albumin-lymphocyte (CALLY) index in Colorectal cancer: A meta-analysis</a:t>
             </a:r>
             <a:endParaRPr lang="en-US" sz="2400" dirty="0"/>
           </a:p>
@@ -4595,7 +4595,7 @@
                   <a:srgbClr val="888888"/>
                 </a:solidFill>
               </a:rPr>
-              <a:t>International immunopharmacology  ·  Basic Research  ·  🌏 Asia</a:t>
+              <a:t>Clinics and Research in Hepatology and …  ·  Meta-Analysis</a:t>
             </a:r>
             <a:endParaRPr lang="en-US" sz="1000" dirty="0"/>
           </a:p>
@@ -4674,7 +4674,7 @@
                   <a:srgbClr val="888888"/>
                 </a:solidFill>
               </a:rPr>
-              <a:t>Wang Shibao, Cai Hengyu, Dai Enyong et al.. International immunopharmacology. 2026-09-18 DOI: 10.1016/j.intimp.2026.117408</a:t>
+              <a:t>X Li, T Chu, W Chen. Clinics and Research in Hepatology and …. 2026</a:t>
             </a:r>
             <a:endParaRPr lang="en-US" sz="800" dirty="0"/>
           </a:p>
@@ -4874,7 +4874,7 @@
                   </a:extLst>
                 </a:hlinkClick>
               </a:rPr>
-              <a:t>Prognostic value of systemic immune-inflammation index for colorectal cancer: a systematic review and meta-analysis</a:t>
+              <a:t>Fatty Acid Heterogeneity in Colorectal Cancer: From Food Matrices to Targeted Interventions.</a:t>
             </a:r>
             <a:endParaRPr lang="en-US" sz="2400" dirty="0"/>
           </a:p>
@@ -4910,7 +4910,7 @@
                   <a:srgbClr val="888888"/>
                 </a:solidFill>
               </a:rPr>
-              <a:t>Frontiers in Oncology  ·  Meta-Analysis</a:t>
+              <a:t>Cancers  ·  Prospective Study</a:t>
             </a:r>
             <a:endParaRPr lang="en-US" sz="1000" dirty="0"/>
           </a:p>
@@ -4989,7 +4989,7 @@
                   <a:srgbClr val="888888"/>
                 </a:solidFill>
               </a:rPr>
-              <a:t>P Wang, H Jiang. Frontiers in Oncology. 2026</a:t>
+              <a:t>Vera Mar&amp;#xed;a Jes&amp;#xfa;s, Farias Camila, Mu&amp;#xf1;oz Yasna et al.. Cancers. 2026-09-26 DOI: 10.3390/cancers18183059</a:t>
             </a:r>
             <a:endParaRPr lang="en-US" sz="800" dirty="0"/>
           </a:p>
@@ -5189,7 +5189,7 @@
                   </a:extLst>
                 </a:hlinkClick>
               </a:rPr>
-              <a:t>Predictive utility of the C-reactive protein-albumin-lymphocyte (CALLY) index in Colorectal cancer: A meta-analysis</a:t>
+              <a:t>Multi-omic profiling identifies TREM2+ lipid-laden macrophages as inflammatory drivers and therapeutic targets of colorectal cancer liver metastasis.</a:t>
             </a:r>
             <a:endParaRPr lang="en-US" sz="2400" dirty="0"/>
           </a:p>
@@ -5225,7 +5225,7 @@
                   <a:srgbClr val="888888"/>
                 </a:solidFill>
               </a:rPr>
-              <a:t>Clinics and Research in Hepatology and …  ·  Meta-Analysis</a:t>
+              <a:t>Cancer letters  ·  Basic Research</a:t>
             </a:r>
             <a:endParaRPr lang="en-US" sz="1000" dirty="0"/>
           </a:p>
@@ -5304,7 +5304,7 @@
                   <a:srgbClr val="888888"/>
                 </a:solidFill>
               </a:rPr>
-              <a:t>X Li, T Chu, W Chen. Clinics and Research in Hepatology and …. 2026</a:t>
+              <a:t>Wang Peng-Xiang, Zhong Yu-Chen, Zheng Wen-Jing et al.. Cancer letters. 2026-07-08 DOI: 10.1016/j.canlet.2026.218657</a:t>
             </a:r>
             <a:endParaRPr lang="en-US" sz="800" dirty="0"/>
           </a:p>
@@ -5504,7 +5504,7 @@
                   </a:extLst>
                 </a:hlinkClick>
               </a:rPr>
-              <a:t>Magnetothermal Wax Capsule for Localized Gastrointestinal Drug Delivery.</a:t>
+              <a:t>Vesicular QSOX1-MMP2 from inflammatory cancer-associated fibroblasts degrades the extracellular matrix to drive colorectal cancer pulmonary dissemination.</a:t>
             </a:r>
             <a:endParaRPr lang="en-US" sz="2400" dirty="0"/>
           </a:p>
@@ -5540,7 +5540,7 @@
                   <a:srgbClr val="888888"/>
                 </a:solidFill>
               </a:rPr>
-              <a:t>ACS applied bio materials  ·  Basic Research</a:t>
+              <a:t>Cancer letters  ·  Basic Research</a:t>
             </a:r>
             <a:endParaRPr lang="en-US" sz="1000" dirty="0"/>
           </a:p>
@@ -5619,7 +5619,7 @@
                   <a:srgbClr val="888888"/>
                 </a:solidFill>
               </a:rPr>
-              <a:t>Zhang Yuming, Zhang Kai, Juriga-T&amp;#xf3;th Krisztina et al.. ACS applied bio materials. 2026-09-19 DOI: 10.1021/acsabm.6c01141</a:t>
+              <a:t>Ye Tingwei, Chen Mengxi, Hu Yu et al.. Cancer letters. 2026-07-08 DOI: 10.1016/j.canlet.2026.218645</a:t>
             </a:r>
             <a:endParaRPr lang="en-US" sz="800" dirty="0"/>
           </a:p>
@@ -5819,7 +5819,7 @@
                   </a:extLst>
                 </a:hlinkClick>
               </a:rPr>
-              <a:t>Batri-7 Attenuates Established Inflammation-Associated Colorectal Adenoma via PI3K/AKT Inhibition and BAX-Associated Apoptosis.</a:t>
+              <a:t>Targeted Colorectal Cancer Therapy Using Cabozantinib-Loaded PLGA Nanoparticles: Formulation, Cytotoxicity, and Molecular Docking Analysis.</a:t>
             </a:r>
             <a:endParaRPr lang="en-US" sz="2400" dirty="0"/>
           </a:p>
@@ -5855,7 +5855,7 @@
                   <a:srgbClr val="888888"/>
                 </a:solidFill>
               </a:rPr>
-              <a:t>Journal of ethnopharmacology  ·  Basic Research</a:t>
+              <a:t>Chemistry (Weinheim an der Bergstrasse, Germany)  ·  Basic Research</a:t>
             </a:r>
             <a:endParaRPr lang="en-US" sz="1000" dirty="0"/>
           </a:p>
@@ -5934,7 +5934,7 @@
                   <a:srgbClr val="888888"/>
                 </a:solidFill>
               </a:rPr>
-              <a:t>Yang Zhiqing, Liu Fangyuan, Sun Xuemeng et al.. Journal of ethnopharmacology. 2026-09-18 DOI: 10.1016/j.jep.2026.122368</a:t>
+              <a:t>Thakkar Aryan, Bhattacharya Sankha, Shinde Ranajit Nivrutti. Chemistry (Weinheim an der Bergstrasse, Germany). 2026-09-25 DOI: 10.1002/chem.71732</a:t>
             </a:r>
             <a:endParaRPr lang="en-US" sz="800" dirty="0"/>
           </a:p>
@@ -6134,7 +6134,7 @@
                   </a:extLst>
                 </a:hlinkClick>
               </a:rPr>
-              <a:t>Shaoyao Decoction Inhibits Colorectal Cancer Progression by Targeting PD-L1 to Reprogram the Immunosuppressive Tumor Microenvironment.</a:t>
+              <a:t>A novel human Streptomyces strain redresses malignancy by inducing apoptosis and regaining gut homeostasis.</a:t>
             </a:r>
             <a:endParaRPr lang="en-US" sz="2400" dirty="0"/>
           </a:p>
@@ -6170,7 +6170,7 @@
                   <a:srgbClr val="888888"/>
                 </a:solidFill>
               </a:rPr>
-              <a:t>Applied biochemistry and biotechnology  ·  Basic Research</a:t>
+              <a:t>mSystems  ·  Basic Research</a:t>
             </a:r>
             <a:endParaRPr lang="en-US" sz="1000" dirty="0"/>
           </a:p>
@@ -6249,7 +6249,7 @@
                   <a:srgbClr val="888888"/>
                 </a:solidFill>
               </a:rPr>
-              <a:t>Wang Xiaoyan, Mima Zhuoga, Sai Wujie et al.. Applied biochemistry and biotechnology. 2026-09-18 DOI: 10.1007/s12010-026-05926-0</a:t>
+              <a:t>Wang Yu-Hui, Yuan Bao-Juan, Meng Yao et al.. mSystems. 2026-09-23 DOI: 10.1128/msystems.00528-26</a:t>
             </a:r>
             <a:endParaRPr lang="en-US" sz="800" dirty="0"/>
           </a:p>

</xml_diff>